<commit_message>
Remove JEA Contacts document to eliminate potential PII exposure
</commit_message>
<xml_diff>
--- a/08_Presentations_Concepts/Tabletop Smart Grid & Distribution Automation Trainer REV2.pptx
+++ b/08_Presentations_Concepts/Tabletop Smart Grid & Distribution Automation Trainer REV2.pptx
@@ -277,7 +277,7 @@
           <a:p>
             <a:fld id="{010502DD-6525-4B73-81D9-80FC8A1FC22F}" type="datetimeFigureOut">
               <a:rPr lang="en-US" smtClean="0"/>
-              <a:t>8/27/2026</a:t>
+              <a:t>9/17/2026</a:t>
             </a:fld>
             <a:endParaRPr lang="en-US"/>
           </a:p>
@@ -475,7 +475,7 @@
           <a:p>
             <a:fld id="{010502DD-6525-4B73-81D9-80FC8A1FC22F}" type="datetimeFigureOut">
               <a:rPr lang="en-US" smtClean="0"/>
-              <a:t>8/27/2026</a:t>
+              <a:t>9/17/2026</a:t>
             </a:fld>
             <a:endParaRPr lang="en-US"/>
           </a:p>
@@ -683,7 +683,7 @@
           <a:p>
             <a:fld id="{010502DD-6525-4B73-81D9-80FC8A1FC22F}" type="datetimeFigureOut">
               <a:rPr lang="en-US" smtClean="0"/>
-              <a:t>8/27/2026</a:t>
+              <a:t>9/17/2026</a:t>
             </a:fld>
             <a:endParaRPr lang="en-US"/>
           </a:p>
@@ -881,7 +881,7 @@
           <a:p>
             <a:fld id="{010502DD-6525-4B73-81D9-80FC8A1FC22F}" type="datetimeFigureOut">
               <a:rPr lang="en-US" smtClean="0"/>
-              <a:t>8/27/2026</a:t>
+              <a:t>9/17/2026</a:t>
             </a:fld>
             <a:endParaRPr lang="en-US"/>
           </a:p>
@@ -1156,7 +1156,7 @@
           <a:p>
             <a:fld id="{010502DD-6525-4B73-81D9-80FC8A1FC22F}" type="datetimeFigureOut">
               <a:rPr lang="en-US" smtClean="0"/>
-              <a:t>8/27/2026</a:t>
+              <a:t>9/17/2026</a:t>
             </a:fld>
             <a:endParaRPr lang="en-US"/>
           </a:p>
@@ -1421,7 +1421,7 @@
           <a:p>
             <a:fld id="{010502DD-6525-4B73-81D9-80FC8A1FC22F}" type="datetimeFigureOut">
               <a:rPr lang="en-US" smtClean="0"/>
-              <a:t>8/27/2026</a:t>
+              <a:t>9/17/2026</a:t>
             </a:fld>
             <a:endParaRPr lang="en-US"/>
           </a:p>
@@ -1833,7 +1833,7 @@
           <a:p>
             <a:fld id="{010502DD-6525-4B73-81D9-80FC8A1FC22F}" type="datetimeFigureOut">
               <a:rPr lang="en-US" smtClean="0"/>
-              <a:t>8/27/2026</a:t>
+              <a:t>9/17/2026</a:t>
             </a:fld>
             <a:endParaRPr lang="en-US"/>
           </a:p>
@@ -1974,7 +1974,7 @@
           <a:p>
             <a:fld id="{010502DD-6525-4B73-81D9-80FC8A1FC22F}" type="datetimeFigureOut">
               <a:rPr lang="en-US" smtClean="0"/>
-              <a:t>8/27/2026</a:t>
+              <a:t>9/17/2026</a:t>
             </a:fld>
             <a:endParaRPr lang="en-US"/>
           </a:p>
@@ -2087,7 +2087,7 @@
           <a:p>
             <a:fld id="{010502DD-6525-4B73-81D9-80FC8A1FC22F}" type="datetimeFigureOut">
               <a:rPr lang="en-US" smtClean="0"/>
-              <a:t>8/27/2026</a:t>
+              <a:t>9/17/2026</a:t>
             </a:fld>
             <a:endParaRPr lang="en-US"/>
           </a:p>
@@ -2398,7 +2398,7 @@
           <a:p>
             <a:fld id="{010502DD-6525-4B73-81D9-80FC8A1FC22F}" type="datetimeFigureOut">
               <a:rPr lang="en-US" smtClean="0"/>
-              <a:t>8/27/2026</a:t>
+              <a:t>9/17/2026</a:t>
             </a:fld>
             <a:endParaRPr lang="en-US"/>
           </a:p>
@@ -2686,7 +2686,7 @@
           <a:p>
             <a:fld id="{010502DD-6525-4B73-81D9-80FC8A1FC22F}" type="datetimeFigureOut">
               <a:rPr lang="en-US" smtClean="0"/>
-              <a:t>8/27/2026</a:t>
+              <a:t>9/17/2026</a:t>
             </a:fld>
             <a:endParaRPr lang="en-US"/>
           </a:p>
@@ -2927,7 +2927,7 @@
           <a:p>
             <a:fld id="{010502DD-6525-4B73-81D9-80FC8A1FC22F}" type="datetimeFigureOut">
               <a:rPr lang="en-US" smtClean="0"/>
-              <a:t>8/27/2026</a:t>
+              <a:t>9/17/2026</a:t>
             </a:fld>
             <a:endParaRPr lang="en-US"/>
           </a:p>
@@ -6544,7 +6544,7 @@
             </a:pPr>
             <a:r>
               <a:rPr lang="en-US" sz="1800" dirty="0"/>
-              <a:t>Email: zwadley@jaxenergy.com</a:t>
+              <a:t>Email: REDACT</a:t>
             </a:r>
           </a:p>
           <a:p>
@@ -6553,7 +6553,7 @@
             </a:pPr>
             <a:r>
               <a:rPr lang="en-US" sz="1800" dirty="0"/>
-              <a:t>Cell: 731.499.0906</a:t>
+              <a:t>Cell: REDACT</a:t>
             </a:r>
           </a:p>
           <a:p>

</xml_diff>